<commit_message>
docs(pitch): update slide 4 packet regeneration innovation flow in pitch deck
</commit_message>
<xml_diff>
--- a/docs/pitch/KHOJ_pitch.pptx
+++ b/docs/pitch/KHOJ_pitch.pptx
@@ -6469,7 +6469,7 @@
                 </a:solidFill>
                 <a:latin typeface="Calibri"/>
               </a:rPr>
-              <a:t>MAIN INNOVATION</a:t>
+              <a:t>OUR INNOVATION</a:t>
             </a:r>
           </a:p>
         </p:txBody>
@@ -6504,7 +6504,7 @@
                 </a:solidFill>
                 <a:latin typeface="Calibri"/>
               </a:rPr>
-              <a:t>Packet regeneration with on-device AI</a:t>
+              <a:t>The mesh heals itself: packet regeneration</a:t>
             </a:r>
           </a:p>
         </p:txBody>
@@ -6546,14 +6546,102 @@
       </p:sp>
       <p:sp>
         <p:nvSpPr>
-          <p:cNvPr id="5" name="TextBox 4"/>
+          <p:cNvPr id="5" name="Rounded Rectangle 4"/>
+          <p:cNvSpPr/>
+          <p:nvPr/>
+        </p:nvSpPr>
+        <p:spPr>
+          <a:xfrm>
+            <a:off x="548640" y="1645920"/>
+            <a:ext cx="3566160" cy="2651760"/>
+          </a:xfrm>
+          <a:prstGeom prst="roundRect">
+            <a:avLst>
+              <a:gd name="adj" fmla="val 8000"/>
+            </a:avLst>
+          </a:prstGeom>
+          <a:solidFill>
+            <a:srgbClr val="1A223C"/>
+          </a:solidFill>
+          <a:ln>
+            <a:noFill/>
+          </a:ln>
+        </p:spPr>
+        <p:style>
+          <a:lnRef idx="1">
+            <a:schemeClr val="accent1"/>
+          </a:lnRef>
+          <a:fillRef idx="3">
+            <a:schemeClr val="accent1"/>
+          </a:fillRef>
+          <a:effectRef idx="2">
+            <a:schemeClr val="accent1"/>
+          </a:effectRef>
+          <a:fontRef idx="minor">
+            <a:schemeClr val="lt1"/>
+          </a:fontRef>
+        </p:style>
+        <p:txBody>
+          <a:bodyPr rtlCol="0" anchor="ctr"/>
+          <a:lstStyle/>
+          <a:p>
+            <a:pPr algn="ctr"/>
+          </a:p>
+        </p:txBody>
+      </p:sp>
+      <p:sp>
+        <p:nvSpPr>
+          <p:cNvPr id="6" name="Rectangle 5"/>
+          <p:cNvSpPr/>
+          <p:nvPr/>
+        </p:nvSpPr>
+        <p:spPr>
+          <a:xfrm>
+            <a:off x="548640" y="1810512"/>
+            <a:ext cx="64008" cy="365760"/>
+          </a:xfrm>
+          <a:prstGeom prst="rect">
+            <a:avLst/>
+          </a:prstGeom>
+          <a:solidFill>
+            <a:srgbClr val="FFB84D"/>
+          </a:solidFill>
+          <a:ln>
+            <a:noFill/>
+          </a:ln>
+        </p:spPr>
+        <p:style>
+          <a:lnRef idx="1">
+            <a:schemeClr val="accent1"/>
+          </a:lnRef>
+          <a:fillRef idx="3">
+            <a:schemeClr val="accent1"/>
+          </a:fillRef>
+          <a:effectRef idx="2">
+            <a:schemeClr val="accent1"/>
+          </a:effectRef>
+          <a:fontRef idx="minor">
+            <a:schemeClr val="lt1"/>
+          </a:fontRef>
+        </p:style>
+        <p:txBody>
+          <a:bodyPr rtlCol="0" anchor="ctr"/>
+          <a:lstStyle/>
+          <a:p>
+            <a:pPr algn="ctr"/>
+          </a:p>
+        </p:txBody>
+      </p:sp>
+      <p:sp>
+        <p:nvSpPr>
+          <p:cNvPr id="7" name="TextBox 6"/>
           <p:cNvSpPr txBox="1"/>
           <p:nvPr/>
         </p:nvSpPr>
         <p:spPr>
           <a:xfrm>
-            <a:off x="548640" y="1554480"/>
-            <a:ext cx="5669280" cy="457200"/>
+            <a:off x="731520" y="1755648"/>
+            <a:ext cx="3246120" cy="457200"/>
           </a:xfrm>
           <a:prstGeom prst="rect">
             <a:avLst/>
@@ -6568,27 +6656,27 @@
           <a:p>
             <a:pPr algn="l"/>
             <a:r>
-              <a:rPr sz="1900" b="1">
-                <a:solidFill>
-                  <a:srgbClr val="FF5A4F"/>
+              <a:rPr sz="1700" b="1">
+                <a:solidFill>
+                  <a:srgbClr val="FFFFFF"/>
                 </a:solidFill>
                 <a:latin typeface="Calibri"/>
               </a:rPr>
-              <a:t>The problem</a:t>
-            </a:r>
-          </a:p>
-        </p:txBody>
-      </p:sp>
-      <p:sp>
-        <p:nvSpPr>
-          <p:cNvPr id="6" name="TextBox 5"/>
+              <a:t>1. What the phone already knows</a:t>
+            </a:r>
+          </a:p>
+        </p:txBody>
+      </p:sp>
+      <p:sp>
+        <p:nvSpPr>
+          <p:cNvPr id="8" name="TextBox 7"/>
           <p:cNvSpPr txBox="1"/>
           <p:nvPr/>
         </p:nvSpPr>
         <p:spPr>
           <a:xfrm>
-            <a:off x="548640" y="1965960"/>
-            <a:ext cx="5486400" cy="1097280"/>
+            <a:off x="731520" y="2212848"/>
+            <a:ext cx="3246120" cy="2011680"/>
           </a:xfrm>
           <a:prstGeom prst="rect">
             <a:avLst/>
@@ -6603,64 +6691,29 @@
           <a:p>
             <a:pPr algn="l"/>
             <a:r>
-              <a:rPr sz="1500" b="0">
-                <a:solidFill>
-                  <a:srgbClr val="FFFFFF"/>
+              <a:rPr sz="1300" b="0">
+                <a:solidFill>
+                  <a:srgbClr val="A9B3CC"/>
                 </a:solidFill>
                 <a:latin typeface="Calibri"/>
               </a:rPr>
-              <a:t>In a dense crowd, Bluetooth packets are lost to collisions and bursts of interference. Today the mesh recovers by retrying.</a:t>
-            </a:r>
-          </a:p>
-        </p:txBody>
-      </p:sp>
-      <p:sp>
-        <p:nvSpPr>
-          <p:cNvPr id="7" name="TextBox 6"/>
-          <p:cNvSpPr txBox="1"/>
-          <p:nvPr/>
-        </p:nvSpPr>
-        <p:spPr>
-          <a:xfrm>
-            <a:off x="548640" y="3017520"/>
-            <a:ext cx="5669280" cy="457200"/>
-          </a:xfrm>
-          <a:prstGeom prst="rect">
-            <a:avLst/>
-          </a:prstGeom>
-          <a:noFill/>
-        </p:spPr>
-        <p:txBody>
-          <a:bodyPr wrap="square">
-            <a:spAutoFit/>
-          </a:bodyPr>
-          <a:lstStyle/>
-          <a:p>
-            <a:pPr algn="l"/>
-            <a:r>
-              <a:rPr sz="1900" b="1">
-                <a:solidFill>
-                  <a:srgbClr val="FF5A4F"/>
-                </a:solidFill>
-                <a:latin typeface="Calibri"/>
-              </a:rPr>
-              <a:t>The idea</a:t>
-            </a:r>
-          </a:p>
-        </p:txBody>
-      </p:sp>
-      <p:sp>
-        <p:nvSpPr>
-          <p:cNvPr id="8" name="Oval 7"/>
+              <a:t>Last known location. Timestamp and how old it is. Speed and motion (walking, still). Signal-strength history. Copies of the packet relayed by neighbours.</a:t>
+            </a:r>
+          </a:p>
+        </p:txBody>
+      </p:sp>
+      <p:sp>
+        <p:nvSpPr>
+          <p:cNvPr id="9" name="Right Arrow 8"/>
           <p:cNvSpPr/>
           <p:nvPr/>
         </p:nvSpPr>
         <p:spPr>
           <a:xfrm>
-            <a:off x="548640" y="3575303"/>
-            <a:ext cx="118872" cy="118872"/>
-          </a:xfrm>
-          <a:prstGeom prst="ellipse">
+            <a:off x="4206240" y="2651760"/>
+            <a:ext cx="457200" cy="457200"/>
+          </a:xfrm>
+          <a:prstGeom prst="rightArrow">
             <a:avLst/>
           </a:prstGeom>
           <a:solidFill>
@@ -6694,51 +6747,61 @@
       </p:sp>
       <p:sp>
         <p:nvSpPr>
-          <p:cNvPr id="9" name="TextBox 8"/>
-          <p:cNvSpPr txBox="1"/>
-          <p:nvPr/>
-        </p:nvSpPr>
-        <p:spPr>
-          <a:xfrm>
-            <a:off x="777240" y="3474720"/>
-            <a:ext cx="5349240" cy="868680"/>
-          </a:xfrm>
-          <a:prstGeom prst="rect">
-            <a:avLst/>
-          </a:prstGeom>
-          <a:noFill/>
-        </p:spPr>
-        <p:txBody>
-          <a:bodyPr wrap="square">
-            <a:spAutoFit/>
-          </a:bodyPr>
-          <a:lstStyle/>
-          <a:p>
-            <a:pPr algn="l"/>
-            <a:r>
-              <a:rPr sz="1400" b="0">
-                <a:solidFill>
-                  <a:srgbClr val="FFFFFF"/>
-                </a:solidFill>
-                <a:latin typeface="Calibri"/>
-              </a:rPr>
-              <a:t>A phone that misses a packet rebuilds it from the other packets it did receive (relays from neighbours, and parity).</a:t>
-            </a:r>
-          </a:p>
-        </p:txBody>
-      </p:sp>
-      <p:sp>
-        <p:nvSpPr>
-          <p:cNvPr id="10" name="Oval 9"/>
+          <p:cNvPr id="10" name="Rounded Rectangle 9"/>
           <p:cNvSpPr/>
           <p:nvPr/>
         </p:nvSpPr>
         <p:spPr>
           <a:xfrm>
-            <a:off x="548640" y="4443984"/>
-            <a:ext cx="118872" cy="118872"/>
-          </a:xfrm>
-          <a:prstGeom prst="ellipse">
+            <a:off x="4754880" y="1645920"/>
+            <a:ext cx="3566160" cy="2651760"/>
+          </a:xfrm>
+          <a:prstGeom prst="roundRect">
+            <a:avLst>
+              <a:gd name="adj" fmla="val 8000"/>
+            </a:avLst>
+          </a:prstGeom>
+          <a:solidFill>
+            <a:srgbClr val="1A223C"/>
+          </a:solidFill>
+          <a:ln>
+            <a:noFill/>
+          </a:ln>
+        </p:spPr>
+        <p:style>
+          <a:lnRef idx="1">
+            <a:schemeClr val="accent1"/>
+          </a:lnRef>
+          <a:fillRef idx="3">
+            <a:schemeClr val="accent1"/>
+          </a:fillRef>
+          <a:effectRef idx="2">
+            <a:schemeClr val="accent1"/>
+          </a:effectRef>
+          <a:fontRef idx="minor">
+            <a:schemeClr val="lt1"/>
+          </a:fontRef>
+        </p:style>
+        <p:txBody>
+          <a:bodyPr rtlCol="0" anchor="ctr"/>
+          <a:lstStyle/>
+          <a:p>
+            <a:pPr algn="ctr"/>
+          </a:p>
+        </p:txBody>
+      </p:sp>
+      <p:sp>
+        <p:nvSpPr>
+          <p:cNvPr id="11" name="Rectangle 10"/>
+          <p:cNvSpPr/>
+          <p:nvPr/>
+        </p:nvSpPr>
+        <p:spPr>
+          <a:xfrm>
+            <a:off x="4754880" y="1810512"/>
+            <a:ext cx="64008" cy="365760"/>
+          </a:xfrm>
+          <a:prstGeom prst="rect">
             <a:avLst/>
           </a:prstGeom>
           <a:solidFill>
@@ -6772,14 +6835,14 @@
       </p:sp>
       <p:sp>
         <p:nvSpPr>
-          <p:cNvPr id="11" name="TextBox 10"/>
+          <p:cNvPr id="12" name="TextBox 11"/>
           <p:cNvSpPr txBox="1"/>
           <p:nvPr/>
         </p:nvSpPr>
         <p:spPr>
           <a:xfrm>
-            <a:off x="777240" y="4343400"/>
-            <a:ext cx="5349240" cy="868680"/>
+            <a:off x="4937760" y="1755648"/>
+            <a:ext cx="3246120" cy="457200"/>
           </a:xfrm>
           <a:prstGeom prst="rect">
             <a:avLst/>
@@ -6794,29 +6857,64 @@
           <a:p>
             <a:pPr algn="l"/>
             <a:r>
-              <a:rPr sz="1400" b="0">
+              <a:rPr sz="1700" b="1">
                 <a:solidFill>
                   <a:srgbClr val="FFFFFF"/>
                 </a:solidFill>
                 <a:latin typeface="Calibri"/>
               </a:rPr>
-              <a:t>A small model fills the gaps using what it already knows: last position, motion and time.</a:t>
-            </a:r>
-          </a:p>
-        </p:txBody>
-      </p:sp>
-      <p:sp>
-        <p:nvSpPr>
-          <p:cNvPr id="12" name="Oval 11"/>
+              <a:t>2. On-device AI on the NPU</a:t>
+            </a:r>
+          </a:p>
+        </p:txBody>
+      </p:sp>
+      <p:sp>
+        <p:nvSpPr>
+          <p:cNvPr id="13" name="TextBox 12"/>
+          <p:cNvSpPr txBox="1"/>
+          <p:nvPr/>
+        </p:nvSpPr>
+        <p:spPr>
+          <a:xfrm>
+            <a:off x="4937760" y="2212848"/>
+            <a:ext cx="3246120" cy="2011680"/>
+          </a:xfrm>
+          <a:prstGeom prst="rect">
+            <a:avLst/>
+          </a:prstGeom>
+          <a:noFill/>
+        </p:spPr>
+        <p:txBody>
+          <a:bodyPr wrap="square">
+            <a:spAutoFit/>
+          </a:bodyPr>
+          <a:lstStyle/>
+          <a:p>
+            <a:pPr algn="l"/>
+            <a:r>
+              <a:rPr sz="1300" b="0">
+                <a:solidFill>
+                  <a:srgbClr val="A9B3CC"/>
+                </a:solidFill>
+                <a:latin typeface="Calibri"/>
+              </a:rPr>
+              <a:t>A small model trained on a laptop, exported to LiteRT and run on the phone's Qualcomm NPU through the QNN delegate. Fast, private, no internet.</a:t>
+            </a:r>
+          </a:p>
+        </p:txBody>
+      </p:sp>
+      <p:sp>
+        <p:nvSpPr>
+          <p:cNvPr id="14" name="Right Arrow 13"/>
           <p:cNvSpPr/>
           <p:nvPr/>
         </p:nvSpPr>
         <p:spPr>
           <a:xfrm>
-            <a:off x="548640" y="5312664"/>
-            <a:ext cx="118872" cy="118872"/>
-          </a:xfrm>
-          <a:prstGeom prst="ellipse">
+            <a:off x="8412480" y="2651760"/>
+            <a:ext cx="457200" cy="457200"/>
+          </a:xfrm>
+          <a:prstGeom prst="rightArrow">
             <a:avLst/>
           </a:prstGeom>
           <a:solidFill>
@@ -6850,49 +6948,14 @@
       </p:sp>
       <p:sp>
         <p:nvSpPr>
-          <p:cNvPr id="13" name="TextBox 12"/>
-          <p:cNvSpPr txBox="1"/>
-          <p:nvPr/>
-        </p:nvSpPr>
-        <p:spPr>
-          <a:xfrm>
-            <a:off x="777240" y="5212079"/>
-            <a:ext cx="5349240" cy="868680"/>
-          </a:xfrm>
-          <a:prstGeom prst="rect">
-            <a:avLst/>
-          </a:prstGeom>
-          <a:noFill/>
-        </p:spPr>
-        <p:txBody>
-          <a:bodyPr wrap="square">
-            <a:spAutoFit/>
-          </a:bodyPr>
-          <a:lstStyle/>
-          <a:p>
-            <a:pPr algn="l"/>
-            <a:r>
-              <a:rPr sz="1400" b="0">
-                <a:solidFill>
-                  <a:srgbClr val="FFFFFF"/>
-                </a:solidFill>
-                <a:latin typeface="Calibri"/>
-              </a:rPr>
-              <a:t>The model is trained on a laptop, then exported and run on the phone's Qualcomm NPU with the QNN delegate.</a:t>
-            </a:r>
-          </a:p>
-        </p:txBody>
-      </p:sp>
-      <p:sp>
-        <p:nvSpPr>
-          <p:cNvPr id="14" name="Rounded Rectangle 13"/>
+          <p:cNvPr id="15" name="Rounded Rectangle 14"/>
           <p:cNvSpPr/>
           <p:nvPr/>
         </p:nvSpPr>
         <p:spPr>
           <a:xfrm>
-            <a:off x="6675120" y="1645920"/>
-            <a:ext cx="4937760" cy="1600200"/>
+            <a:off x="8961120" y="1645920"/>
+            <a:ext cx="2697480" cy="2651760"/>
           </a:xfrm>
           <a:prstGeom prst="roundRect">
             <a:avLst>
@@ -6930,13 +6993,13 @@
       </p:sp>
       <p:sp>
         <p:nvSpPr>
-          <p:cNvPr id="15" name="Rectangle 14"/>
+          <p:cNvPr id="16" name="Rectangle 15"/>
           <p:cNvSpPr/>
           <p:nvPr/>
         </p:nvSpPr>
         <p:spPr>
           <a:xfrm>
-            <a:off x="6675120" y="1810512"/>
+            <a:off x="8961120" y="1810512"/>
             <a:ext cx="64008" cy="365760"/>
           </a:xfrm>
           <a:prstGeom prst="rect">
@@ -6973,14 +7036,14 @@
       </p:sp>
       <p:sp>
         <p:nvSpPr>
-          <p:cNvPr id="16" name="TextBox 15"/>
+          <p:cNvPr id="17" name="TextBox 16"/>
           <p:cNvSpPr txBox="1"/>
           <p:nvPr/>
         </p:nvSpPr>
         <p:spPr>
           <a:xfrm>
-            <a:off x="6858000" y="1755648"/>
-            <a:ext cx="4617720" cy="457200"/>
+            <a:off x="9144000" y="1755648"/>
+            <a:ext cx="2377440" cy="457200"/>
           </a:xfrm>
           <a:prstGeom prst="rect">
             <a:avLst/>
@@ -6995,27 +7058,27 @@
           <a:p>
             <a:pPr algn="l"/>
             <a:r>
-              <a:rPr sz="1600" b="1">
+              <a:rPr sz="1700" b="1">
                 <a:solidFill>
                   <a:srgbClr val="FFFFFF"/>
                 </a:solidFill>
                 <a:latin typeface="Calibri"/>
               </a:rPr>
-              <a:t>What exists today</a:t>
-            </a:r>
-          </a:p>
-        </p:txBody>
-      </p:sp>
-      <p:sp>
-        <p:nvSpPr>
-          <p:cNvPr id="17" name="TextBox 16"/>
+              <a:t>3. Regenerated packet</a:t>
+            </a:r>
+          </a:p>
+        </p:txBody>
+      </p:sp>
+      <p:sp>
+        <p:nvSpPr>
+          <p:cNvPr id="18" name="TextBox 17"/>
           <p:cNvSpPr txBox="1"/>
           <p:nvPr/>
         </p:nvSpPr>
         <p:spPr>
           <a:xfrm>
-            <a:off x="6858000" y="2212848"/>
-            <a:ext cx="4617720" cy="960120"/>
+            <a:off x="9144000" y="2212848"/>
+            <a:ext cx="2377440" cy="2011680"/>
           </a:xfrm>
           <a:prstGeom prst="rect">
             <a:avLst/>
@@ -7036,21 +7099,21 @@
                 </a:solidFill>
                 <a:latin typeface="Calibri"/>
               </a:rPr>
-              <a:t>Reed-Solomon recovery in direct sharing: 92.8% delivery vs 54.6% without it on bursty loss (simulation). A loss-predictor model already runs on the NPU path (currently paused).</a:t>
-            </a:r>
-          </a:p>
-        </p:txBody>
-      </p:sp>
-      <p:sp>
-        <p:nvSpPr>
-          <p:cNvPr id="18" name="Rounded Rectangle 17"/>
+              <a:t>The missing update is rebuilt and tagged regenerated, with a confidence. A real packet replaces it the moment one arrives.</a:t>
+            </a:r>
+          </a:p>
+        </p:txBody>
+      </p:sp>
+      <p:sp>
+        <p:nvSpPr>
+          <p:cNvPr id="19" name="Rounded Rectangle 18"/>
           <p:cNvSpPr/>
           <p:nvPr/>
         </p:nvSpPr>
         <p:spPr>
           <a:xfrm>
-            <a:off x="6675120" y="3429000"/>
-            <a:ext cx="4937760" cy="1600200"/>
+            <a:off x="548640" y="4526280"/>
+            <a:ext cx="3657600" cy="1691640"/>
           </a:xfrm>
           <a:prstGeom prst="roundRect">
             <a:avLst>
@@ -7088,13 +7151,329 @@
       </p:sp>
       <p:sp>
         <p:nvSpPr>
-          <p:cNvPr id="19" name="Rectangle 18"/>
+          <p:cNvPr id="20" name="Rectangle 19"/>
           <p:cNvSpPr/>
           <p:nvPr/>
         </p:nvSpPr>
         <p:spPr>
           <a:xfrm>
-            <a:off x="6675120" y="3593592"/>
+            <a:off x="548640" y="4690872"/>
+            <a:ext cx="64008" cy="365760"/>
+          </a:xfrm>
+          <a:prstGeom prst="rect">
+            <a:avLst/>
+          </a:prstGeom>
+          <a:solidFill>
+            <a:srgbClr val="4CD98B"/>
+          </a:solidFill>
+          <a:ln>
+            <a:noFill/>
+          </a:ln>
+        </p:spPr>
+        <p:style>
+          <a:lnRef idx="1">
+            <a:schemeClr val="accent1"/>
+          </a:lnRef>
+          <a:fillRef idx="3">
+            <a:schemeClr val="accent1"/>
+          </a:fillRef>
+          <a:effectRef idx="2">
+            <a:schemeClr val="accent1"/>
+          </a:effectRef>
+          <a:fontRef idx="minor">
+            <a:schemeClr val="lt1"/>
+          </a:fontRef>
+        </p:style>
+        <p:txBody>
+          <a:bodyPr rtlCol="0" anchor="ctr"/>
+          <a:lstStyle/>
+          <a:p>
+            <a:pPr algn="ctr"/>
+          </a:p>
+        </p:txBody>
+      </p:sp>
+      <p:sp>
+        <p:nvSpPr>
+          <p:cNvPr id="21" name="TextBox 20"/>
+          <p:cNvSpPr txBox="1"/>
+          <p:nvPr/>
+        </p:nvSpPr>
+        <p:spPr>
+          <a:xfrm>
+            <a:off x="731520" y="4636008"/>
+            <a:ext cx="3337560" cy="457200"/>
+          </a:xfrm>
+          <a:prstGeom prst="rect">
+            <a:avLst/>
+          </a:prstGeom>
+          <a:noFill/>
+        </p:spPr>
+        <p:txBody>
+          <a:bodyPr wrap="square">
+            <a:spAutoFit/>
+          </a:bodyPr>
+          <a:lstStyle/>
+          <a:p>
+            <a:pPr algn="l"/>
+            <a:r>
+              <a:rPr sz="1600" b="1">
+                <a:solidFill>
+                  <a:srgbClr val="FFFFFF"/>
+                </a:solidFill>
+                <a:latin typeface="Calibri"/>
+              </a:rPr>
+              <a:t>Why it matters</a:t>
+            </a:r>
+          </a:p>
+        </p:txBody>
+      </p:sp>
+      <p:sp>
+        <p:nvSpPr>
+          <p:cNvPr id="22" name="TextBox 21"/>
+          <p:cNvSpPr txBox="1"/>
+          <p:nvPr/>
+        </p:nvSpPr>
+        <p:spPr>
+          <a:xfrm>
+            <a:off x="731520" y="5093208"/>
+            <a:ext cx="3337560" cy="1051560"/>
+          </a:xfrm>
+          <a:prstGeom prst="rect">
+            <a:avLst/>
+          </a:prstGeom>
+          <a:noFill/>
+        </p:spPr>
+        <p:txBody>
+          <a:bodyPr wrap="square">
+            <a:spAutoFit/>
+          </a:bodyPr>
+          <a:lstStyle/>
+          <a:p>
+            <a:pPr algn="l"/>
+            <a:r>
+              <a:rPr sz="1300" b="0">
+                <a:solidFill>
+                  <a:srgbClr val="A9B3CC"/>
+                </a:solidFill>
+                <a:latin typeface="Calibri"/>
+              </a:rPr>
+              <a:t>In a crowd, packets drop in bursts. Instead of a family member vanishing from the radar, their last good data fills the gap.</a:t>
+            </a:r>
+          </a:p>
+        </p:txBody>
+      </p:sp>
+      <p:sp>
+        <p:nvSpPr>
+          <p:cNvPr id="23" name="Rounded Rectangle 22"/>
+          <p:cNvSpPr/>
+          <p:nvPr/>
+        </p:nvSpPr>
+        <p:spPr>
+          <a:xfrm>
+            <a:off x="4343400" y="4526280"/>
+            <a:ext cx="3657600" cy="1691640"/>
+          </a:xfrm>
+          <a:prstGeom prst="roundRect">
+            <a:avLst>
+              <a:gd name="adj" fmla="val 8000"/>
+            </a:avLst>
+          </a:prstGeom>
+          <a:solidFill>
+            <a:srgbClr val="1A223C"/>
+          </a:solidFill>
+          <a:ln>
+            <a:noFill/>
+          </a:ln>
+        </p:spPr>
+        <p:style>
+          <a:lnRef idx="1">
+            <a:schemeClr val="accent1"/>
+          </a:lnRef>
+          <a:fillRef idx="3">
+            <a:schemeClr val="accent1"/>
+          </a:fillRef>
+          <a:effectRef idx="2">
+            <a:schemeClr val="accent1"/>
+          </a:effectRef>
+          <a:fontRef idx="minor">
+            <a:schemeClr val="lt1"/>
+          </a:fontRef>
+        </p:style>
+        <p:txBody>
+          <a:bodyPr rtlCol="0" anchor="ctr"/>
+          <a:lstStyle/>
+          <a:p>
+            <a:pPr algn="ctr"/>
+          </a:p>
+        </p:txBody>
+      </p:sp>
+      <p:sp>
+        <p:nvSpPr>
+          <p:cNvPr id="24" name="Rectangle 23"/>
+          <p:cNvSpPr/>
+          <p:nvPr/>
+        </p:nvSpPr>
+        <p:spPr>
+          <a:xfrm>
+            <a:off x="4343400" y="4690872"/>
+            <a:ext cx="64008" cy="365760"/>
+          </a:xfrm>
+          <a:prstGeom prst="rect">
+            <a:avLst/>
+          </a:prstGeom>
+          <a:solidFill>
+            <a:srgbClr val="FF5A4F"/>
+          </a:solidFill>
+          <a:ln>
+            <a:noFill/>
+          </a:ln>
+        </p:spPr>
+        <p:style>
+          <a:lnRef idx="1">
+            <a:schemeClr val="accent1"/>
+          </a:lnRef>
+          <a:fillRef idx="3">
+            <a:schemeClr val="accent1"/>
+          </a:fillRef>
+          <a:effectRef idx="2">
+            <a:schemeClr val="accent1"/>
+          </a:effectRef>
+          <a:fontRef idx="minor">
+            <a:schemeClr val="lt1"/>
+          </a:fontRef>
+        </p:style>
+        <p:txBody>
+          <a:bodyPr rtlCol="0" anchor="ctr"/>
+          <a:lstStyle/>
+          <a:p>
+            <a:pPr algn="ctr"/>
+          </a:p>
+        </p:txBody>
+      </p:sp>
+      <p:sp>
+        <p:nvSpPr>
+          <p:cNvPr id="25" name="TextBox 24"/>
+          <p:cNvSpPr txBox="1"/>
+          <p:nvPr/>
+        </p:nvSpPr>
+        <p:spPr>
+          <a:xfrm>
+            <a:off x="4526280" y="4636008"/>
+            <a:ext cx="3337560" cy="457200"/>
+          </a:xfrm>
+          <a:prstGeom prst="rect">
+            <a:avLst/>
+          </a:prstGeom>
+          <a:noFill/>
+        </p:spPr>
+        <p:txBody>
+          <a:bodyPr wrap="square">
+            <a:spAutoFit/>
+          </a:bodyPr>
+          <a:lstStyle/>
+          <a:p>
+            <a:pPr algn="l"/>
+            <a:r>
+              <a:rPr sz="1600" b="1">
+                <a:solidFill>
+                  <a:srgbClr val="FFFFFF"/>
+                </a:solidFill>
+                <a:latin typeface="Calibri"/>
+              </a:rPr>
+              <a:t>Safety rule</a:t>
+            </a:r>
+          </a:p>
+        </p:txBody>
+      </p:sp>
+      <p:sp>
+        <p:nvSpPr>
+          <p:cNvPr id="26" name="TextBox 25"/>
+          <p:cNvSpPr txBox="1"/>
+          <p:nvPr/>
+        </p:nvSpPr>
+        <p:spPr>
+          <a:xfrm>
+            <a:off x="4526280" y="5093208"/>
+            <a:ext cx="3337560" cy="1051560"/>
+          </a:xfrm>
+          <a:prstGeom prst="rect">
+            <a:avLst/>
+          </a:prstGeom>
+          <a:noFill/>
+        </p:spPr>
+        <p:txBody>
+          <a:bodyPr wrap="square">
+            <a:spAutoFit/>
+          </a:bodyPr>
+          <a:lstStyle/>
+          <a:p>
+            <a:pPr algn="l"/>
+            <a:r>
+              <a:rPr sz="1300" b="0">
+                <a:solidFill>
+                  <a:srgbClr val="A9B3CC"/>
+                </a:solidFill>
+                <a:latin typeface="Calibri"/>
+              </a:rPr>
+              <a:t>A regenerated position is never shown as live. If the gap passes 20 seconds, KHOJ shows nothing rather than guess.</a:t>
+            </a:r>
+          </a:p>
+        </p:txBody>
+      </p:sp>
+      <p:sp>
+        <p:nvSpPr>
+          <p:cNvPr id="27" name="Rounded Rectangle 26"/>
+          <p:cNvSpPr/>
+          <p:nvPr/>
+        </p:nvSpPr>
+        <p:spPr>
+          <a:xfrm>
+            <a:off x="8138160" y="4526280"/>
+            <a:ext cx="3520440" cy="1691640"/>
+          </a:xfrm>
+          <a:prstGeom prst="roundRect">
+            <a:avLst>
+              <a:gd name="adj" fmla="val 8000"/>
+            </a:avLst>
+          </a:prstGeom>
+          <a:solidFill>
+            <a:srgbClr val="1A223C"/>
+          </a:solidFill>
+          <a:ln>
+            <a:noFill/>
+          </a:ln>
+        </p:spPr>
+        <p:style>
+          <a:lnRef idx="1">
+            <a:schemeClr val="accent1"/>
+          </a:lnRef>
+          <a:fillRef idx="3">
+            <a:schemeClr val="accent1"/>
+          </a:fillRef>
+          <a:effectRef idx="2">
+            <a:schemeClr val="accent1"/>
+          </a:effectRef>
+          <a:fontRef idx="minor">
+            <a:schemeClr val="lt1"/>
+          </a:fontRef>
+        </p:style>
+        <p:txBody>
+          <a:bodyPr rtlCol="0" anchor="ctr"/>
+          <a:lstStyle/>
+          <a:p>
+            <a:pPr algn="ctr"/>
+          </a:p>
+        </p:txBody>
+      </p:sp>
+      <p:sp>
+        <p:nvSpPr>
+          <p:cNvPr id="28" name="Rectangle 27"/>
+          <p:cNvSpPr/>
+          <p:nvPr/>
+        </p:nvSpPr>
+        <p:spPr>
+          <a:xfrm>
+            <a:off x="8138160" y="4690872"/>
             <a:ext cx="64008" cy="365760"/>
           </a:xfrm>
           <a:prstGeom prst="rect">
@@ -7131,14 +7510,14 @@
       </p:sp>
       <p:sp>
         <p:nvSpPr>
-          <p:cNvPr id="20" name="TextBox 19"/>
+          <p:cNvPr id="29" name="TextBox 28"/>
           <p:cNvSpPr txBox="1"/>
           <p:nvPr/>
         </p:nvSpPr>
         <p:spPr>
           <a:xfrm>
-            <a:off x="6858000" y="3538728"/>
-            <a:ext cx="4617720" cy="457200"/>
+            <a:off x="8321040" y="4636008"/>
+            <a:ext cx="3200400" cy="457200"/>
           </a:xfrm>
           <a:prstGeom prst="rect">
             <a:avLst/>
@@ -7159,21 +7538,21 @@
                 </a:solidFill>
                 <a:latin typeface="Calibri"/>
               </a:rPr>
-              <a:t>What we are building</a:t>
-            </a:r>
-          </a:p>
-        </p:txBody>
-      </p:sp>
-      <p:sp>
-        <p:nvSpPr>
-          <p:cNvPr id="21" name="TextBox 20"/>
+              <a:t>Status, honestly</a:t>
+            </a:r>
+          </a:p>
+        </p:txBody>
+      </p:sp>
+      <p:sp>
+        <p:nvSpPr>
+          <p:cNvPr id="30" name="TextBox 29"/>
           <p:cNvSpPr txBox="1"/>
           <p:nvPr/>
         </p:nvSpPr>
         <p:spPr>
           <a:xfrm>
-            <a:off x="6858000" y="3995928"/>
-            <a:ext cx="4617720" cy="960120"/>
+            <a:off x="8321040" y="5093208"/>
+            <a:ext cx="3200400" cy="1051560"/>
           </a:xfrm>
           <a:prstGeom prst="rect">
             <a:avLst/>
@@ -7188,171 +7567,13 @@
           <a:p>
             <a:pPr algn="l"/>
             <a:r>
-              <a:rPr sz="1300" b="0">
+              <a:rPr sz="1200" b="0">
                 <a:solidFill>
                   <a:srgbClr val="A9B3CC"/>
                 </a:solidFill>
                 <a:latin typeface="Calibri"/>
               </a:rPr>
-              <a:t>Regeneration inside the mesh itself. This is the design and prototype stage; there are no measured results for it yet.</a:t>
-            </a:r>
-          </a:p>
-        </p:txBody>
-      </p:sp>
-      <p:sp>
-        <p:nvSpPr>
-          <p:cNvPr id="22" name="Rounded Rectangle 21"/>
-          <p:cNvSpPr/>
-          <p:nvPr/>
-        </p:nvSpPr>
-        <p:spPr>
-          <a:xfrm>
-            <a:off x="6675120" y="5212080"/>
-            <a:ext cx="4937760" cy="1097280"/>
-          </a:xfrm>
-          <a:prstGeom prst="roundRect">
-            <a:avLst>
-              <a:gd name="adj" fmla="val 8000"/>
-            </a:avLst>
-          </a:prstGeom>
-          <a:solidFill>
-            <a:srgbClr val="1A223C"/>
-          </a:solidFill>
-          <a:ln>
-            <a:noFill/>
-          </a:ln>
-        </p:spPr>
-        <p:style>
-          <a:lnRef idx="1">
-            <a:schemeClr val="accent1"/>
-          </a:lnRef>
-          <a:fillRef idx="3">
-            <a:schemeClr val="accent1"/>
-          </a:fillRef>
-          <a:effectRef idx="2">
-            <a:schemeClr val="accent1"/>
-          </a:effectRef>
-          <a:fontRef idx="minor">
-            <a:schemeClr val="lt1"/>
-          </a:fontRef>
-        </p:style>
-        <p:txBody>
-          <a:bodyPr rtlCol="0" anchor="ctr"/>
-          <a:lstStyle/>
-          <a:p>
-            <a:pPr algn="ctr"/>
-          </a:p>
-        </p:txBody>
-      </p:sp>
-      <p:sp>
-        <p:nvSpPr>
-          <p:cNvPr id="23" name="Rectangle 22"/>
-          <p:cNvSpPr/>
-          <p:nvPr/>
-        </p:nvSpPr>
-        <p:spPr>
-          <a:xfrm>
-            <a:off x="6675120" y="5376672"/>
-            <a:ext cx="64008" cy="365760"/>
-          </a:xfrm>
-          <a:prstGeom prst="rect">
-            <a:avLst/>
-          </a:prstGeom>
-          <a:solidFill>
-            <a:srgbClr val="FF5A4F"/>
-          </a:solidFill>
-          <a:ln>
-            <a:noFill/>
-          </a:ln>
-        </p:spPr>
-        <p:style>
-          <a:lnRef idx="1">
-            <a:schemeClr val="accent1"/>
-          </a:lnRef>
-          <a:fillRef idx="3">
-            <a:schemeClr val="accent1"/>
-          </a:fillRef>
-          <a:effectRef idx="2">
-            <a:schemeClr val="accent1"/>
-          </a:effectRef>
-          <a:fontRef idx="minor">
-            <a:schemeClr val="lt1"/>
-          </a:fontRef>
-        </p:style>
-        <p:txBody>
-          <a:bodyPr rtlCol="0" anchor="ctr"/>
-          <a:lstStyle/>
-          <a:p>
-            <a:pPr algn="ctr"/>
-          </a:p>
-        </p:txBody>
-      </p:sp>
-      <p:sp>
-        <p:nvSpPr>
-          <p:cNvPr id="24" name="TextBox 23"/>
-          <p:cNvSpPr txBox="1"/>
-          <p:nvPr/>
-        </p:nvSpPr>
-        <p:spPr>
-          <a:xfrm>
-            <a:off x="6858000" y="5321808"/>
-            <a:ext cx="4617720" cy="457200"/>
-          </a:xfrm>
-          <a:prstGeom prst="rect">
-            <a:avLst/>
-          </a:prstGeom>
-          <a:noFill/>
-        </p:spPr>
-        <p:txBody>
-          <a:bodyPr wrap="square">
-            <a:spAutoFit/>
-          </a:bodyPr>
-          <a:lstStyle/>
-          <a:p>
-            <a:pPr algn="l"/>
-            <a:r>
-              <a:rPr sz="1600" b="1">
-                <a:solidFill>
-                  <a:srgbClr val="FFFFFF"/>
-                </a:solidFill>
-                <a:latin typeface="Calibri"/>
-              </a:rPr>
-              <a:t>Honest limit</a:t>
-            </a:r>
-          </a:p>
-        </p:txBody>
-      </p:sp>
-      <p:sp>
-        <p:nvSpPr>
-          <p:cNvPr id="25" name="TextBox 24"/>
-          <p:cNvSpPr txBox="1"/>
-          <p:nvPr/>
-        </p:nvSpPr>
-        <p:spPr>
-          <a:xfrm>
-            <a:off x="6858000" y="5779008"/>
-            <a:ext cx="4617720" cy="457200"/>
-          </a:xfrm>
-          <a:prstGeom prst="rect">
-            <a:avLst/>
-          </a:prstGeom>
-          <a:noFill/>
-        </p:spPr>
-        <p:txBody>
-          <a:bodyPr wrap="square">
-            <a:spAutoFit/>
-          </a:bodyPr>
-          <a:lstStyle/>
-          <a:p>
-            <a:pPr algn="l"/>
-            <a:r>
-              <a:rPr sz="1300" b="0">
-                <a:solidFill>
-                  <a:srgbClr val="A9B3CC"/>
-                </a:solidFill>
-                <a:latin typeface="Calibri"/>
-              </a:rPr>
-              <a:t>It improves delivery inside the existing range. It does not extend Bluetooth range.</a:t>
+              <a:t>Design and prototype. Reed-Solomon recovery in direct sharing: 92.8% vs 54.6% (simulation). No measured regeneration results yet. It does not extend range.</a:t>
             </a:r>
           </a:p>
         </p:txBody>

</xml_diff>